<commit_message>
feat: add new slides and markdown files for AI Guardrails and Technical Debt topics
</commit_message>
<xml_diff>
--- a/Slides/individual-slides/Adding AI Guardrails.pptx
+++ b/Slides/individual-slides/Adding AI Guardrails.pptx
@@ -162,6 +162,9 @@
         </p14:section>
       </p14:sectionLst>
     </p:ext>
+    <p:ext uri="{EFAFB233-063F-42B5-8137-9DF3F51BA10A}">
+      <p15:sldGuideLst xmlns:p15="http://schemas.microsoft.com/office/powerpoint/2012/main"/>
+    </p:ext>
   </p:extLst>
 </p:presentation>
 </file>
@@ -248,7 +251,7 @@
           <a:p>
             <a:fld id="{F312A3D0-47F2-40B2-AD2D-E2E0EC88E68B}" type="datetimeFigureOut">
               <a:rPr lang="en-US" smtClean="0"/>
-              <a:t>3/5/2026</a:t>
+              <a:t>3/11/2026</a:t>
             </a:fld>
             <a:endParaRPr lang="en-US"/>
           </a:p>
@@ -2934,7 +2937,7 @@
           <a:p>
             <a:fld id="{0768B094-26DC-41A8-A025-7A3031559A0C}" type="datetimeFigureOut">
               <a:rPr lang="en-US" smtClean="0"/>
-              <a:t>3/5/2026</a:t>
+              <a:t>3/11/2026</a:t>
             </a:fld>
             <a:endParaRPr lang="en-US"/>
           </a:p>
@@ -3132,7 +3135,7 @@
           <a:p>
             <a:fld id="{0768B094-26DC-41A8-A025-7A3031559A0C}" type="datetimeFigureOut">
               <a:rPr lang="en-US" smtClean="0"/>
-              <a:t>3/5/2026</a:t>
+              <a:t>3/11/2026</a:t>
             </a:fld>
             <a:endParaRPr lang="en-US"/>
           </a:p>
@@ -3340,7 +3343,7 @@
           <a:p>
             <a:fld id="{0768B094-26DC-41A8-A025-7A3031559A0C}" type="datetimeFigureOut">
               <a:rPr lang="en-US" smtClean="0"/>
-              <a:t>3/5/2026</a:t>
+              <a:t>3/11/2026</a:t>
             </a:fld>
             <a:endParaRPr lang="en-US"/>
           </a:p>
@@ -3538,7 +3541,7 @@
           <a:p>
             <a:fld id="{0768B094-26DC-41A8-A025-7A3031559A0C}" type="datetimeFigureOut">
               <a:rPr lang="en-US" smtClean="0"/>
-              <a:t>3/5/2026</a:t>
+              <a:t>3/11/2026</a:t>
             </a:fld>
             <a:endParaRPr lang="en-US"/>
           </a:p>
@@ -3813,7 +3816,7 @@
           <a:p>
             <a:fld id="{0768B094-26DC-41A8-A025-7A3031559A0C}" type="datetimeFigureOut">
               <a:rPr lang="en-US" smtClean="0"/>
-              <a:t>3/5/2026</a:t>
+              <a:t>3/11/2026</a:t>
             </a:fld>
             <a:endParaRPr lang="en-US"/>
           </a:p>
@@ -4078,7 +4081,7 @@
           <a:p>
             <a:fld id="{0768B094-26DC-41A8-A025-7A3031559A0C}" type="datetimeFigureOut">
               <a:rPr lang="en-US" smtClean="0"/>
-              <a:t>3/5/2026</a:t>
+              <a:t>3/11/2026</a:t>
             </a:fld>
             <a:endParaRPr lang="en-US"/>
           </a:p>
@@ -4490,7 +4493,7 @@
           <a:p>
             <a:fld id="{0768B094-26DC-41A8-A025-7A3031559A0C}" type="datetimeFigureOut">
               <a:rPr lang="en-US" smtClean="0"/>
-              <a:t>3/5/2026</a:t>
+              <a:t>3/11/2026</a:t>
             </a:fld>
             <a:endParaRPr lang="en-US"/>
           </a:p>
@@ -4631,7 +4634,7 @@
           <a:p>
             <a:fld id="{0768B094-26DC-41A8-A025-7A3031559A0C}" type="datetimeFigureOut">
               <a:rPr lang="en-US" smtClean="0"/>
-              <a:t>3/5/2026</a:t>
+              <a:t>3/11/2026</a:t>
             </a:fld>
             <a:endParaRPr lang="en-US"/>
           </a:p>
@@ -4744,7 +4747,7 @@
           <a:p>
             <a:fld id="{0768B094-26DC-41A8-A025-7A3031559A0C}" type="datetimeFigureOut">
               <a:rPr lang="en-US" smtClean="0"/>
-              <a:t>3/5/2026</a:t>
+              <a:t>3/11/2026</a:t>
             </a:fld>
             <a:endParaRPr lang="en-US"/>
           </a:p>
@@ -5055,7 +5058,7 @@
           <a:p>
             <a:fld id="{0768B094-26DC-41A8-A025-7A3031559A0C}" type="datetimeFigureOut">
               <a:rPr lang="en-US" smtClean="0"/>
-              <a:t>3/5/2026</a:t>
+              <a:t>3/11/2026</a:t>
             </a:fld>
             <a:endParaRPr lang="en-US"/>
           </a:p>
@@ -5343,7 +5346,7 @@
           <a:p>
             <a:fld id="{0768B094-26DC-41A8-A025-7A3031559A0C}" type="datetimeFigureOut">
               <a:rPr lang="en-US" smtClean="0"/>
-              <a:t>3/5/2026</a:t>
+              <a:t>3/11/2026</a:t>
             </a:fld>
             <a:endParaRPr lang="en-US"/>
           </a:p>
@@ -5584,7 +5587,7 @@
           <a:p>
             <a:fld id="{0768B094-26DC-41A8-A025-7A3031559A0C}" type="datetimeFigureOut">
               <a:rPr lang="en-US" smtClean="0"/>
-              <a:t>3/5/2026</a:t>
+              <a:t>3/11/2026</a:t>
             </a:fld>
             <a:endParaRPr lang="en-US"/>
           </a:p>
@@ -6132,7 +6135,7 @@
           <a:lstStyle/>
           <a:p>
             <a:r>
-              <a:rPr b="1"/>
+              <a:rPr b="1" dirty="0"/>
               <a:t>Required Provenance Metadata</a:t>
             </a:r>
           </a:p>
@@ -6259,7 +6262,7 @@
           <a:lstStyle/>
           <a:p>
             <a:r>
-              <a:rPr b="1"/>
+              <a:rPr b="1" dirty="0"/>
               <a:t>Metadata Placement Policy</a:t>
             </a:r>
           </a:p>
@@ -6348,7 +6351,7 @@
           <a:lstStyle/>
           <a:p>
             <a:r>
-              <a:rPr b="1"/>
+              <a:rPr b="1" dirty="0"/>
               <a:t>AI Chat Logging Workflow</a:t>
             </a:r>
           </a:p>
@@ -6455,7 +6458,7 @@
           <a:lstStyle/>
           <a:p>
             <a:r>
-              <a:rPr b="1"/>
+              <a:rPr b="1" dirty="0"/>
               <a:t>Quality &amp; PR Checklist</a:t>
             </a:r>
           </a:p>
@@ -9187,7 +9190,7 @@
           <a:lstStyle/>
           <a:p>
             <a:r>
-              <a:rPr b="1"/>
+              <a:rPr b="1" dirty="0"/>
               <a:t>AI-Assisted Output Instructions</a:t>
             </a:r>
           </a:p>

</xml_diff>